<commit_message>
Request quote feature added
</commit_message>
<xml_diff>
--- a/rendezvous_pitch_deck.pptx
+++ b/rendezvous_pitch_deck.pptx
@@ -5,18 +5,18 @@
     <p:sldMasterId id="2147483648" r:id="rId1"/>
   </p:sldMasterIdLst>
   <p:sldIdLst>
-    <p:sldId id="256" r:id="rId7"/>
-    <p:sldId id="257" r:id="rId8"/>
-    <p:sldId id="258" r:id="rId9"/>
-    <p:sldId id="259" r:id="rId10"/>
-    <p:sldId id="260" r:id="rId11"/>
-    <p:sldId id="261" r:id="rId12"/>
-    <p:sldId id="262" r:id="rId13"/>
-    <p:sldId id="263" r:id="rId14"/>
-    <p:sldId id="264" r:id="rId15"/>
-    <p:sldId id="265" r:id="rId16"/>
+    <p:sldId id="256" r:id="rId2"/>
+    <p:sldId id="257" r:id="rId3"/>
+    <p:sldId id="258" r:id="rId4"/>
+    <p:sldId id="259" r:id="rId5"/>
+    <p:sldId id="260" r:id="rId6"/>
+    <p:sldId id="261" r:id="rId7"/>
+    <p:sldId id="262" r:id="rId8"/>
+    <p:sldId id="263" r:id="rId9"/>
+    <p:sldId id="264" r:id="rId10"/>
+    <p:sldId id="265" r:id="rId11"/>
   </p:sldIdLst>
-  <p:sldSz cx="12188952" cy="6858000" type="screen4x3"/>
+  <p:sldSz cx="12188825" cy="6858000"/>
   <p:notesSz cx="6858000" cy="9144000"/>
   <p:defaultTextStyle>
     <a:defPPr>
@@ -113,6 +113,22 @@
       </a:defRPr>
     </a:lvl9pPr>
   </p:defaultTextStyle>
+  <p:extLst>
+    <p:ext uri="{EFAFB233-063F-42B5-8137-9DF3F51BA10A}">
+      <p15:sldGuideLst xmlns:p15="http://schemas.microsoft.com/office/powerpoint/2012/main">
+        <p15:guide id="1" orient="horz" pos="2160">
+          <p15:clr>
+            <a:srgbClr val="A4A3A4"/>
+          </p15:clr>
+        </p15:guide>
+        <p15:guide id="2" pos="2880">
+          <p15:clr>
+            <a:srgbClr val="A4A3A4"/>
+          </p15:clr>
+        </p15:guide>
+      </p15:sldGuideLst>
+    </p:ext>
+  </p:extLst>
 </p:presentation>
 </file>
 
@@ -154,10 +170,9 @@
           <a:lstStyle/>
           <a:p>
             <a:r>
-              <a:rPr lang="en-US" smtClean="0"/>
+              <a:rPr lang="en-US"/>
               <a:t>Click to edit Master title style</a:t>
             </a:r>
-            <a:endParaRPr lang="en-US"/>
           </a:p>
         </p:txBody>
       </p:sp>
@@ -273,10 +288,9 @@
           </a:lstStyle>
           <a:p>
             <a:r>
-              <a:rPr lang="en-US" smtClean="0"/>
+              <a:rPr lang="en-US"/>
               <a:t>Click to edit Master subtitle style</a:t>
             </a:r>
-            <a:endParaRPr lang="en-US"/>
           </a:p>
         </p:txBody>
       </p:sp>
@@ -297,7 +311,7 @@
           <a:p>
             <a:fld id="{5BCAD085-E8A6-8845-BD4E-CB4CCA059FC4}" type="datetimeFigureOut">
               <a:rPr lang="en-US" smtClean="0"/>
-              <a:t>1/27/13</a:t>
+              <a:t>3/26/2026</a:t>
             </a:fld>
             <a:endParaRPr lang="en-US"/>
           </a:p>
@@ -391,10 +405,9 @@
           <a:lstStyle/>
           <a:p>
             <a:r>
-              <a:rPr lang="en-US" smtClean="0"/>
+              <a:rPr lang="en-US"/>
               <a:t>Click to edit Master title style</a:t>
             </a:r>
-            <a:endParaRPr lang="en-US"/>
           </a:p>
         </p:txBody>
       </p:sp>
@@ -415,38 +428,37 @@
           <a:p>
             <a:pPr lvl="0"/>
             <a:r>
-              <a:rPr lang="en-US" smtClean="0"/>
+              <a:rPr lang="en-US"/>
               <a:t>Click to edit Master text styles</a:t>
             </a:r>
           </a:p>
           <a:p>
             <a:pPr lvl="1"/>
             <a:r>
-              <a:rPr lang="en-US" smtClean="0"/>
+              <a:rPr lang="en-US"/>
               <a:t>Second level</a:t>
             </a:r>
           </a:p>
           <a:p>
             <a:pPr lvl="2"/>
             <a:r>
-              <a:rPr lang="en-US" smtClean="0"/>
+              <a:rPr lang="en-US"/>
               <a:t>Third level</a:t>
             </a:r>
           </a:p>
           <a:p>
             <a:pPr lvl="3"/>
             <a:r>
-              <a:rPr lang="en-US" smtClean="0"/>
+              <a:rPr lang="en-US"/>
               <a:t>Fourth level</a:t>
             </a:r>
           </a:p>
           <a:p>
             <a:pPr lvl="4"/>
             <a:r>
-              <a:rPr lang="en-US" smtClean="0"/>
+              <a:rPr lang="en-US"/>
               <a:t>Fifth level</a:t>
             </a:r>
-            <a:endParaRPr lang="en-US"/>
           </a:p>
         </p:txBody>
       </p:sp>
@@ -467,7 +479,7 @@
           <a:p>
             <a:fld id="{5BCAD085-E8A6-8845-BD4E-CB4CCA059FC4}" type="datetimeFigureOut">
               <a:rPr lang="en-US" smtClean="0"/>
-              <a:t>1/27/13</a:t>
+              <a:t>3/26/2026</a:t>
             </a:fld>
             <a:endParaRPr lang="en-US"/>
           </a:p>
@@ -566,10 +578,9 @@
           <a:lstStyle/>
           <a:p>
             <a:r>
-              <a:rPr lang="en-US" smtClean="0"/>
+              <a:rPr lang="en-US"/>
               <a:t>Click to edit Master title style</a:t>
             </a:r>
-            <a:endParaRPr lang="en-US"/>
           </a:p>
         </p:txBody>
       </p:sp>
@@ -595,38 +606,37 @@
           <a:p>
             <a:pPr lvl="0"/>
             <a:r>
-              <a:rPr lang="en-US" smtClean="0"/>
+              <a:rPr lang="en-US"/>
               <a:t>Click to edit Master text styles</a:t>
             </a:r>
           </a:p>
           <a:p>
             <a:pPr lvl="1"/>
             <a:r>
-              <a:rPr lang="en-US" smtClean="0"/>
+              <a:rPr lang="en-US"/>
               <a:t>Second level</a:t>
             </a:r>
           </a:p>
           <a:p>
             <a:pPr lvl="2"/>
             <a:r>
-              <a:rPr lang="en-US" smtClean="0"/>
+              <a:rPr lang="en-US"/>
               <a:t>Third level</a:t>
             </a:r>
           </a:p>
           <a:p>
             <a:pPr lvl="3"/>
             <a:r>
-              <a:rPr lang="en-US" smtClean="0"/>
+              <a:rPr lang="en-US"/>
               <a:t>Fourth level</a:t>
             </a:r>
           </a:p>
           <a:p>
             <a:pPr lvl="4"/>
             <a:r>
-              <a:rPr lang="en-US" smtClean="0"/>
+              <a:rPr lang="en-US"/>
               <a:t>Fifth level</a:t>
             </a:r>
-            <a:endParaRPr lang="en-US"/>
           </a:p>
         </p:txBody>
       </p:sp>
@@ -647,7 +657,7 @@
           <a:p>
             <a:fld id="{5BCAD085-E8A6-8845-BD4E-CB4CCA059FC4}" type="datetimeFigureOut">
               <a:rPr lang="en-US" smtClean="0"/>
-              <a:t>1/27/13</a:t>
+              <a:t>3/26/2026</a:t>
             </a:fld>
             <a:endParaRPr lang="en-US"/>
           </a:p>
@@ -741,10 +751,9 @@
           <a:lstStyle/>
           <a:p>
             <a:r>
-              <a:rPr lang="en-US" smtClean="0"/>
+              <a:rPr lang="en-US"/>
               <a:t>Click to edit Master title style</a:t>
             </a:r>
-            <a:endParaRPr lang="en-US"/>
           </a:p>
         </p:txBody>
       </p:sp>
@@ -765,38 +774,37 @@
           <a:p>
             <a:pPr lvl="0"/>
             <a:r>
-              <a:rPr lang="en-US" smtClean="0"/>
+              <a:rPr lang="en-US"/>
               <a:t>Click to edit Master text styles</a:t>
             </a:r>
           </a:p>
           <a:p>
             <a:pPr lvl="1"/>
             <a:r>
-              <a:rPr lang="en-US" smtClean="0"/>
+              <a:rPr lang="en-US"/>
               <a:t>Second level</a:t>
             </a:r>
           </a:p>
           <a:p>
             <a:pPr lvl="2"/>
             <a:r>
-              <a:rPr lang="en-US" smtClean="0"/>
+              <a:rPr lang="en-US"/>
               <a:t>Third level</a:t>
             </a:r>
           </a:p>
           <a:p>
             <a:pPr lvl="3"/>
             <a:r>
-              <a:rPr lang="en-US" smtClean="0"/>
+              <a:rPr lang="en-US"/>
               <a:t>Fourth level</a:t>
             </a:r>
           </a:p>
           <a:p>
             <a:pPr lvl="4"/>
             <a:r>
-              <a:rPr lang="en-US" smtClean="0"/>
+              <a:rPr lang="en-US"/>
               <a:t>Fifth level</a:t>
             </a:r>
-            <a:endParaRPr lang="en-US"/>
           </a:p>
         </p:txBody>
       </p:sp>
@@ -817,7 +825,7 @@
           <a:p>
             <a:fld id="{5BCAD085-E8A6-8845-BD4E-CB4CCA059FC4}" type="datetimeFigureOut">
               <a:rPr lang="en-US" smtClean="0"/>
-              <a:t>1/27/13</a:t>
+              <a:t>3/26/2026</a:t>
             </a:fld>
             <a:endParaRPr lang="en-US"/>
           </a:p>
@@ -920,10 +928,9 @@
           </a:lstStyle>
           <a:p>
             <a:r>
-              <a:rPr lang="en-US" smtClean="0"/>
+              <a:rPr lang="en-US"/>
               <a:t>Click to edit Master title style</a:t>
             </a:r>
-            <a:endParaRPr lang="en-US"/>
           </a:p>
         </p:txBody>
       </p:sp>
@@ -1040,7 +1047,7 @@
           <a:p>
             <a:pPr lvl="0"/>
             <a:r>
-              <a:rPr lang="en-US" smtClean="0"/>
+              <a:rPr lang="en-US"/>
               <a:t>Click to edit Master text styles</a:t>
             </a:r>
           </a:p>
@@ -1063,7 +1070,7 @@
           <a:p>
             <a:fld id="{5BCAD085-E8A6-8845-BD4E-CB4CCA059FC4}" type="datetimeFigureOut">
               <a:rPr lang="en-US" smtClean="0"/>
-              <a:t>1/27/13</a:t>
+              <a:t>3/26/2026</a:t>
             </a:fld>
             <a:endParaRPr lang="en-US"/>
           </a:p>
@@ -1157,10 +1164,9 @@
           <a:lstStyle/>
           <a:p>
             <a:r>
-              <a:rPr lang="en-US" smtClean="0"/>
+              <a:rPr lang="en-US"/>
               <a:t>Click to edit Master title style</a:t>
             </a:r>
-            <a:endParaRPr lang="en-US"/>
           </a:p>
         </p:txBody>
       </p:sp>
@@ -1214,38 +1220,37 @@
           <a:p>
             <a:pPr lvl="0"/>
             <a:r>
-              <a:rPr lang="en-US" smtClean="0"/>
+              <a:rPr lang="en-US"/>
               <a:t>Click to edit Master text styles</a:t>
             </a:r>
           </a:p>
           <a:p>
             <a:pPr lvl="1"/>
             <a:r>
-              <a:rPr lang="en-US" smtClean="0"/>
+              <a:rPr lang="en-US"/>
               <a:t>Second level</a:t>
             </a:r>
           </a:p>
           <a:p>
             <a:pPr lvl="2"/>
             <a:r>
-              <a:rPr lang="en-US" smtClean="0"/>
+              <a:rPr lang="en-US"/>
               <a:t>Third level</a:t>
             </a:r>
           </a:p>
           <a:p>
             <a:pPr lvl="3"/>
             <a:r>
-              <a:rPr lang="en-US" smtClean="0"/>
+              <a:rPr lang="en-US"/>
               <a:t>Fourth level</a:t>
             </a:r>
           </a:p>
           <a:p>
             <a:pPr lvl="4"/>
             <a:r>
-              <a:rPr lang="en-US" smtClean="0"/>
+              <a:rPr lang="en-US"/>
               <a:t>Fifth level</a:t>
             </a:r>
-            <a:endParaRPr lang="en-US"/>
           </a:p>
         </p:txBody>
       </p:sp>
@@ -1299,38 +1304,37 @@
           <a:p>
             <a:pPr lvl="0"/>
             <a:r>
-              <a:rPr lang="en-US" smtClean="0"/>
+              <a:rPr lang="en-US"/>
               <a:t>Click to edit Master text styles</a:t>
             </a:r>
           </a:p>
           <a:p>
             <a:pPr lvl="1"/>
             <a:r>
-              <a:rPr lang="en-US" smtClean="0"/>
+              <a:rPr lang="en-US"/>
               <a:t>Second level</a:t>
             </a:r>
           </a:p>
           <a:p>
             <a:pPr lvl="2"/>
             <a:r>
-              <a:rPr lang="en-US" smtClean="0"/>
+              <a:rPr lang="en-US"/>
               <a:t>Third level</a:t>
             </a:r>
           </a:p>
           <a:p>
             <a:pPr lvl="3"/>
             <a:r>
-              <a:rPr lang="en-US" smtClean="0"/>
+              <a:rPr lang="en-US"/>
               <a:t>Fourth level</a:t>
             </a:r>
           </a:p>
           <a:p>
             <a:pPr lvl="4"/>
             <a:r>
-              <a:rPr lang="en-US" smtClean="0"/>
+              <a:rPr lang="en-US"/>
               <a:t>Fifth level</a:t>
             </a:r>
-            <a:endParaRPr lang="en-US"/>
           </a:p>
         </p:txBody>
       </p:sp>
@@ -1351,7 +1355,7 @@
           <a:p>
             <a:fld id="{5BCAD085-E8A6-8845-BD4E-CB4CCA059FC4}" type="datetimeFigureOut">
               <a:rPr lang="en-US" smtClean="0"/>
-              <a:t>1/27/13</a:t>
+              <a:t>3/26/2026</a:t>
             </a:fld>
             <a:endParaRPr lang="en-US"/>
           </a:p>
@@ -1449,10 +1453,9 @@
           </a:lstStyle>
           <a:p>
             <a:r>
-              <a:rPr lang="en-US" smtClean="0"/>
+              <a:rPr lang="en-US"/>
               <a:t>Click to edit Master title style</a:t>
             </a:r>
-            <a:endParaRPr lang="en-US"/>
           </a:p>
         </p:txBody>
       </p:sp>
@@ -1515,7 +1518,7 @@
           <a:p>
             <a:pPr lvl="0"/>
             <a:r>
-              <a:rPr lang="en-US" smtClean="0"/>
+              <a:rPr lang="en-US"/>
               <a:t>Click to edit Master text styles</a:t>
             </a:r>
           </a:p>
@@ -1571,38 +1574,37 @@
           <a:p>
             <a:pPr lvl="0"/>
             <a:r>
-              <a:rPr lang="en-US" smtClean="0"/>
+              <a:rPr lang="en-US"/>
               <a:t>Click to edit Master text styles</a:t>
             </a:r>
           </a:p>
           <a:p>
             <a:pPr lvl="1"/>
             <a:r>
-              <a:rPr lang="en-US" smtClean="0"/>
+              <a:rPr lang="en-US"/>
               <a:t>Second level</a:t>
             </a:r>
           </a:p>
           <a:p>
             <a:pPr lvl="2"/>
             <a:r>
-              <a:rPr lang="en-US" smtClean="0"/>
+              <a:rPr lang="en-US"/>
               <a:t>Third level</a:t>
             </a:r>
           </a:p>
           <a:p>
             <a:pPr lvl="3"/>
             <a:r>
-              <a:rPr lang="en-US" smtClean="0"/>
+              <a:rPr lang="en-US"/>
               <a:t>Fourth level</a:t>
             </a:r>
           </a:p>
           <a:p>
             <a:pPr lvl="4"/>
             <a:r>
-              <a:rPr lang="en-US" smtClean="0"/>
+              <a:rPr lang="en-US"/>
               <a:t>Fifth level</a:t>
             </a:r>
-            <a:endParaRPr lang="en-US"/>
           </a:p>
         </p:txBody>
       </p:sp>
@@ -1665,7 +1667,7 @@
           <a:p>
             <a:pPr lvl="0"/>
             <a:r>
-              <a:rPr lang="en-US" smtClean="0"/>
+              <a:rPr lang="en-US"/>
               <a:t>Click to edit Master text styles</a:t>
             </a:r>
           </a:p>
@@ -1721,38 +1723,37 @@
           <a:p>
             <a:pPr lvl="0"/>
             <a:r>
-              <a:rPr lang="en-US" smtClean="0"/>
+              <a:rPr lang="en-US"/>
               <a:t>Click to edit Master text styles</a:t>
             </a:r>
           </a:p>
           <a:p>
             <a:pPr lvl="1"/>
             <a:r>
-              <a:rPr lang="en-US" smtClean="0"/>
+              <a:rPr lang="en-US"/>
               <a:t>Second level</a:t>
             </a:r>
           </a:p>
           <a:p>
             <a:pPr lvl="2"/>
             <a:r>
-              <a:rPr lang="en-US" smtClean="0"/>
+              <a:rPr lang="en-US"/>
               <a:t>Third level</a:t>
             </a:r>
           </a:p>
           <a:p>
             <a:pPr lvl="3"/>
             <a:r>
-              <a:rPr lang="en-US" smtClean="0"/>
+              <a:rPr lang="en-US"/>
               <a:t>Fourth level</a:t>
             </a:r>
           </a:p>
           <a:p>
             <a:pPr lvl="4"/>
             <a:r>
-              <a:rPr lang="en-US" smtClean="0"/>
+              <a:rPr lang="en-US"/>
               <a:t>Fifth level</a:t>
             </a:r>
-            <a:endParaRPr lang="en-US"/>
           </a:p>
         </p:txBody>
       </p:sp>
@@ -1773,7 +1774,7 @@
           <a:p>
             <a:fld id="{5BCAD085-E8A6-8845-BD4E-CB4CCA059FC4}" type="datetimeFigureOut">
               <a:rPr lang="en-US" smtClean="0"/>
-              <a:t>1/27/13</a:t>
+              <a:t>3/26/2026</a:t>
             </a:fld>
             <a:endParaRPr lang="en-US"/>
           </a:p>
@@ -1867,10 +1868,9 @@
           <a:lstStyle/>
           <a:p>
             <a:r>
-              <a:rPr lang="en-US" smtClean="0"/>
+              <a:rPr lang="en-US"/>
               <a:t>Click to edit Master title style</a:t>
             </a:r>
-            <a:endParaRPr lang="en-US"/>
           </a:p>
         </p:txBody>
       </p:sp>
@@ -1891,7 +1891,7 @@
           <a:p>
             <a:fld id="{5BCAD085-E8A6-8845-BD4E-CB4CCA059FC4}" type="datetimeFigureOut">
               <a:rPr lang="en-US" smtClean="0"/>
-              <a:t>1/27/13</a:t>
+              <a:t>3/26/2026</a:t>
             </a:fld>
             <a:endParaRPr lang="en-US"/>
           </a:p>
@@ -1986,7 +1986,7 @@
           <a:p>
             <a:fld id="{5BCAD085-E8A6-8845-BD4E-CB4CCA059FC4}" type="datetimeFigureOut">
               <a:rPr lang="en-US" smtClean="0"/>
-              <a:t>1/27/13</a:t>
+              <a:t>3/26/2026</a:t>
             </a:fld>
             <a:endParaRPr lang="en-US"/>
           </a:p>
@@ -2089,10 +2089,9 @@
           </a:lstStyle>
           <a:p>
             <a:r>
-              <a:rPr lang="en-US" smtClean="0"/>
+              <a:rPr lang="en-US"/>
               <a:t>Click to edit Master title style</a:t>
             </a:r>
-            <a:endParaRPr lang="en-US"/>
           </a:p>
         </p:txBody>
       </p:sp>
@@ -2146,38 +2145,37 @@
           <a:p>
             <a:pPr lvl="0"/>
             <a:r>
-              <a:rPr lang="en-US" smtClean="0"/>
+              <a:rPr lang="en-US"/>
               <a:t>Click to edit Master text styles</a:t>
             </a:r>
           </a:p>
           <a:p>
             <a:pPr lvl="1"/>
             <a:r>
-              <a:rPr lang="en-US" smtClean="0"/>
+              <a:rPr lang="en-US"/>
               <a:t>Second level</a:t>
             </a:r>
           </a:p>
           <a:p>
             <a:pPr lvl="2"/>
             <a:r>
-              <a:rPr lang="en-US" smtClean="0"/>
+              <a:rPr lang="en-US"/>
               <a:t>Third level</a:t>
             </a:r>
           </a:p>
           <a:p>
             <a:pPr lvl="3"/>
             <a:r>
-              <a:rPr lang="en-US" smtClean="0"/>
+              <a:rPr lang="en-US"/>
               <a:t>Fourth level</a:t>
             </a:r>
           </a:p>
           <a:p>
             <a:pPr lvl="4"/>
             <a:r>
-              <a:rPr lang="en-US" smtClean="0"/>
+              <a:rPr lang="en-US"/>
               <a:t>Fifth level</a:t>
             </a:r>
-            <a:endParaRPr lang="en-US"/>
           </a:p>
         </p:txBody>
       </p:sp>
@@ -2240,7 +2238,7 @@
           <a:p>
             <a:pPr lvl="0"/>
             <a:r>
-              <a:rPr lang="en-US" smtClean="0"/>
+              <a:rPr lang="en-US"/>
               <a:t>Click to edit Master text styles</a:t>
             </a:r>
           </a:p>
@@ -2263,7 +2261,7 @@
           <a:p>
             <a:fld id="{5BCAD085-E8A6-8845-BD4E-CB4CCA059FC4}" type="datetimeFigureOut">
               <a:rPr lang="en-US" smtClean="0"/>
-              <a:t>1/27/13</a:t>
+              <a:t>3/26/2026</a:t>
             </a:fld>
             <a:endParaRPr lang="en-US"/>
           </a:p>
@@ -2366,10 +2364,9 @@
           </a:lstStyle>
           <a:p>
             <a:r>
-              <a:rPr lang="en-US" smtClean="0"/>
+              <a:rPr lang="en-US"/>
               <a:t>Click to edit Master title style</a:t>
             </a:r>
-            <a:endParaRPr lang="en-US"/>
           </a:p>
         </p:txBody>
       </p:sp>
@@ -2493,7 +2490,7 @@
           <a:p>
             <a:pPr lvl="0"/>
             <a:r>
-              <a:rPr lang="en-US" smtClean="0"/>
+              <a:rPr lang="en-US"/>
               <a:t>Click to edit Master text styles</a:t>
             </a:r>
           </a:p>
@@ -2516,7 +2513,7 @@
           <a:p>
             <a:fld id="{5BCAD085-E8A6-8845-BD4E-CB4CCA059FC4}" type="datetimeFigureOut">
               <a:rPr lang="en-US" smtClean="0"/>
-              <a:t>1/27/13</a:t>
+              <a:t>3/26/2026</a:t>
             </a:fld>
             <a:endParaRPr lang="en-US"/>
           </a:p>
@@ -2625,10 +2622,9 @@
           <a:lstStyle/>
           <a:p>
             <a:r>
-              <a:rPr lang="en-US" smtClean="0"/>
+              <a:rPr lang="en-US"/>
               <a:t>Click to edit Master title style</a:t>
             </a:r>
-            <a:endParaRPr lang="en-US"/>
           </a:p>
         </p:txBody>
       </p:sp>
@@ -2659,38 +2655,37 @@
           <a:p>
             <a:pPr lvl="0"/>
             <a:r>
-              <a:rPr lang="en-US" smtClean="0"/>
+              <a:rPr lang="en-US"/>
               <a:t>Click to edit Master text styles</a:t>
             </a:r>
           </a:p>
           <a:p>
             <a:pPr lvl="1"/>
             <a:r>
-              <a:rPr lang="en-US" smtClean="0"/>
+              <a:rPr lang="en-US"/>
               <a:t>Second level</a:t>
             </a:r>
           </a:p>
           <a:p>
             <a:pPr lvl="2"/>
             <a:r>
-              <a:rPr lang="en-US" smtClean="0"/>
+              <a:rPr lang="en-US"/>
               <a:t>Third level</a:t>
             </a:r>
           </a:p>
           <a:p>
             <a:pPr lvl="3"/>
             <a:r>
-              <a:rPr lang="en-US" smtClean="0"/>
+              <a:rPr lang="en-US"/>
               <a:t>Fourth level</a:t>
             </a:r>
           </a:p>
           <a:p>
             <a:pPr lvl="4"/>
             <a:r>
-              <a:rPr lang="en-US" smtClean="0"/>
+              <a:rPr lang="en-US"/>
               <a:t>Fifth level</a:t>
             </a:r>
-            <a:endParaRPr lang="en-US"/>
           </a:p>
         </p:txBody>
       </p:sp>
@@ -2729,7 +2724,7 @@
           <a:p>
             <a:fld id="{5BCAD085-E8A6-8845-BD4E-CB4CCA059FC4}" type="datetimeFigureOut">
               <a:rPr lang="en-US" smtClean="0"/>
-              <a:t>1/27/13</a:t>
+              <a:t>3/26/2026</a:t>
             </a:fld>
             <a:endParaRPr lang="en-US"/>
           </a:p>
@@ -3088,7 +3083,7 @@
 </file>
 
 <file path=ppt/slides/slide1.xml><?xml version="1.0" encoding="utf-8"?>
-<p:sld xmlns:a="http://schemas.openxmlformats.org/drawingml/2006/main" xmlns:p="http://schemas.openxmlformats.org/presentationml/2006/main" xmlns:r="http://schemas.openxmlformats.org/officeDocument/2006/relationships">
+<p:sld xmlns:a="http://schemas.openxmlformats.org/drawingml/2006/main" xmlns:r="http://schemas.openxmlformats.org/officeDocument/2006/relationships" xmlns:p="http://schemas.openxmlformats.org/presentationml/2006/main">
   <p:cSld>
     <p:bg>
       <p:bgPr>
@@ -3104,7 +3099,14 @@
         <p:cNvGrpSpPr/>
         <p:nvPr/>
       </p:nvGrpSpPr>
-      <p:grpSpPr/>
+      <p:grpSpPr>
+        <a:xfrm>
+          <a:off x="0" y="0"/>
+          <a:ext cx="0" cy="0"/>
+          <a:chOff x="0" y="0"/>
+          <a:chExt cx="0" cy="0"/>
+        </a:xfrm>
+      </p:grpSpPr>
       <p:sp>
         <p:nvSpPr>
           <p:cNvPr id="2" name="Rectangle 1"/>
@@ -3147,6 +3149,7 @@
           <a:lstStyle/>
           <a:p>
             <a:pPr algn="ctr"/>
+            <a:endParaRPr/>
           </a:p>
         </p:txBody>
       </p:sp>
@@ -3192,6 +3195,7 @@
           <a:lstStyle/>
           <a:p>
             <a:pPr algn="ctr"/>
+            <a:endParaRPr/>
           </a:p>
         </p:txBody>
       </p:sp>
@@ -3377,6 +3381,7 @@
           <a:lstStyle/>
           <a:p>
             <a:pPr algn="ctr"/>
+            <a:endParaRPr/>
           </a:p>
         </p:txBody>
       </p:sp>
@@ -3426,7 +3431,7 @@
 </file>
 
 <file path=ppt/slides/slide10.xml><?xml version="1.0" encoding="utf-8"?>
-<p:sld xmlns:a="http://schemas.openxmlformats.org/drawingml/2006/main" xmlns:p="http://schemas.openxmlformats.org/presentationml/2006/main" xmlns:r="http://schemas.openxmlformats.org/officeDocument/2006/relationships">
+<p:sld xmlns:a="http://schemas.openxmlformats.org/drawingml/2006/main" xmlns:r="http://schemas.openxmlformats.org/officeDocument/2006/relationships" xmlns:p="http://schemas.openxmlformats.org/presentationml/2006/main">
   <p:cSld>
     <p:bg>
       <p:bgPr>
@@ -3442,7 +3447,14 @@
         <p:cNvGrpSpPr/>
         <p:nvPr/>
       </p:nvGrpSpPr>
-      <p:grpSpPr/>
+      <p:grpSpPr>
+        <a:xfrm>
+          <a:off x="0" y="0"/>
+          <a:ext cx="0" cy="0"/>
+          <a:chOff x="0" y="0"/>
+          <a:chExt cx="0" cy="0"/>
+        </a:xfrm>
+      </p:grpSpPr>
       <p:sp>
         <p:nvSpPr>
           <p:cNvPr id="2" name="Rectangle 1"/>
@@ -3485,6 +3497,7 @@
           <a:lstStyle/>
           <a:p>
             <a:pPr algn="ctr"/>
+            <a:endParaRPr/>
           </a:p>
         </p:txBody>
       </p:sp>
@@ -3530,6 +3543,7 @@
           <a:lstStyle/>
           <a:p>
             <a:pPr algn="ctr"/>
+            <a:endParaRPr/>
           </a:p>
         </p:txBody>
       </p:sp>
@@ -3858,7 +3872,7 @@
 </file>
 
 <file path=ppt/slides/slide2.xml><?xml version="1.0" encoding="utf-8"?>
-<p:sld xmlns:a="http://schemas.openxmlformats.org/drawingml/2006/main" xmlns:p="http://schemas.openxmlformats.org/presentationml/2006/main" xmlns:r="http://schemas.openxmlformats.org/officeDocument/2006/relationships">
+<p:sld xmlns:a="http://schemas.openxmlformats.org/drawingml/2006/main" xmlns:r="http://schemas.openxmlformats.org/officeDocument/2006/relationships" xmlns:p="http://schemas.openxmlformats.org/presentationml/2006/main">
   <p:cSld>
     <p:bg>
       <p:bgPr>
@@ -3874,7 +3888,14 @@
         <p:cNvGrpSpPr/>
         <p:nvPr/>
       </p:nvGrpSpPr>
-      <p:grpSpPr/>
+      <p:grpSpPr>
+        <a:xfrm>
+          <a:off x="0" y="0"/>
+          <a:ext cx="0" cy="0"/>
+          <a:chOff x="0" y="0"/>
+          <a:chExt cx="0" cy="0"/>
+        </a:xfrm>
+      </p:grpSpPr>
       <p:sp>
         <p:nvSpPr>
           <p:cNvPr id="2" name="TextBox 1"/>
@@ -3952,6 +3973,7 @@
           <a:lstStyle/>
           <a:p>
             <a:pPr algn="ctr"/>
+            <a:endParaRPr/>
           </a:p>
         </p:txBody>
       </p:sp>
@@ -4481,6 +4503,7 @@
           <a:lstStyle/>
           <a:p>
             <a:pPr algn="ctr"/>
+            <a:endParaRPr/>
           </a:p>
         </p:txBody>
       </p:sp>
@@ -4563,7 +4586,7 @@
 </file>
 
 <file path=ppt/slides/slide3.xml><?xml version="1.0" encoding="utf-8"?>
-<p:sld xmlns:a="http://schemas.openxmlformats.org/drawingml/2006/main" xmlns:p="http://schemas.openxmlformats.org/presentationml/2006/main" xmlns:r="http://schemas.openxmlformats.org/officeDocument/2006/relationships">
+<p:sld xmlns:a="http://schemas.openxmlformats.org/drawingml/2006/main" xmlns:r="http://schemas.openxmlformats.org/officeDocument/2006/relationships" xmlns:p="http://schemas.openxmlformats.org/presentationml/2006/main">
   <p:cSld>
     <p:bg>
       <p:bgPr>
@@ -4579,7 +4602,14 @@
         <p:cNvGrpSpPr/>
         <p:nvPr/>
       </p:nvGrpSpPr>
-      <p:grpSpPr/>
+      <p:grpSpPr>
+        <a:xfrm>
+          <a:off x="0" y="0"/>
+          <a:ext cx="0" cy="0"/>
+          <a:chOff x="0" y="0"/>
+          <a:chExt cx="0" cy="0"/>
+        </a:xfrm>
+      </p:grpSpPr>
       <p:sp>
         <p:nvSpPr>
           <p:cNvPr id="2" name="TextBox 1"/>
@@ -4657,6 +4687,7 @@
           <a:lstStyle/>
           <a:p>
             <a:pPr algn="ctr"/>
+            <a:endParaRPr/>
           </a:p>
         </p:txBody>
       </p:sp>
@@ -4982,6 +5013,7 @@
           <a:lstStyle/>
           <a:p>
             <a:pPr algn="ctr"/>
+            <a:endParaRPr/>
           </a:p>
         </p:txBody>
       </p:sp>
@@ -5392,7 +5424,7 @@
 </file>
 
 <file path=ppt/slides/slide4.xml><?xml version="1.0" encoding="utf-8"?>
-<p:sld xmlns:a="http://schemas.openxmlformats.org/drawingml/2006/main" xmlns:p="http://schemas.openxmlformats.org/presentationml/2006/main" xmlns:r="http://schemas.openxmlformats.org/officeDocument/2006/relationships">
+<p:sld xmlns:a="http://schemas.openxmlformats.org/drawingml/2006/main" xmlns:r="http://schemas.openxmlformats.org/officeDocument/2006/relationships" xmlns:p="http://schemas.openxmlformats.org/presentationml/2006/main">
   <p:cSld>
     <p:bg>
       <p:bgPr>
@@ -5408,7 +5440,14 @@
         <p:cNvGrpSpPr/>
         <p:nvPr/>
       </p:nvGrpSpPr>
-      <p:grpSpPr/>
+      <p:grpSpPr>
+        <a:xfrm>
+          <a:off x="0" y="0"/>
+          <a:ext cx="0" cy="0"/>
+          <a:chOff x="0" y="0"/>
+          <a:chExt cx="0" cy="0"/>
+        </a:xfrm>
+      </p:grpSpPr>
       <p:sp>
         <p:nvSpPr>
           <p:cNvPr id="2" name="TextBox 1"/>
@@ -5486,6 +5525,7 @@
           <a:lstStyle/>
           <a:p>
             <a:pPr algn="ctr"/>
+            <a:endParaRPr/>
           </a:p>
         </p:txBody>
       </p:sp>
@@ -5566,6 +5606,7 @@
           <a:lstStyle/>
           <a:p>
             <a:pPr algn="ctr"/>
+            <a:endParaRPr/>
           </a:p>
         </p:txBody>
       </p:sp>
@@ -5767,6 +5808,7 @@
           <a:lstStyle/>
           <a:p>
             <a:pPr algn="ctr"/>
+            <a:endParaRPr/>
           </a:p>
         </p:txBody>
       </p:sp>
@@ -5968,6 +6010,7 @@
           <a:lstStyle/>
           <a:p>
             <a:pPr algn="ctr"/>
+            <a:endParaRPr/>
           </a:p>
         </p:txBody>
       </p:sp>
@@ -6136,7 +6179,7 @@
 </file>
 
 <file path=ppt/slides/slide5.xml><?xml version="1.0" encoding="utf-8"?>
-<p:sld xmlns:a="http://schemas.openxmlformats.org/drawingml/2006/main" xmlns:p="http://schemas.openxmlformats.org/presentationml/2006/main" xmlns:r="http://schemas.openxmlformats.org/officeDocument/2006/relationships">
+<p:sld xmlns:a="http://schemas.openxmlformats.org/drawingml/2006/main" xmlns:r="http://schemas.openxmlformats.org/officeDocument/2006/relationships" xmlns:p="http://schemas.openxmlformats.org/presentationml/2006/main">
   <p:cSld>
     <p:bg>
       <p:bgPr>
@@ -6152,7 +6195,14 @@
         <p:cNvGrpSpPr/>
         <p:nvPr/>
       </p:nvGrpSpPr>
-      <p:grpSpPr/>
+      <p:grpSpPr>
+        <a:xfrm>
+          <a:off x="0" y="0"/>
+          <a:ext cx="0" cy="0"/>
+          <a:chOff x="0" y="0"/>
+          <a:chExt cx="0" cy="0"/>
+        </a:xfrm>
+      </p:grpSpPr>
       <p:sp>
         <p:nvSpPr>
           <p:cNvPr id="2" name="Rectangle 1"/>
@@ -6195,6 +6245,7 @@
           <a:lstStyle/>
           <a:p>
             <a:pPr algn="ctr"/>
+            <a:endParaRPr/>
           </a:p>
         </p:txBody>
       </p:sp>
@@ -6240,6 +6291,7 @@
           <a:lstStyle/>
           <a:p>
             <a:pPr algn="ctr"/>
+            <a:endParaRPr/>
           </a:p>
         </p:txBody>
       </p:sp>
@@ -6532,7 +6584,7 @@
 </file>
 
 <file path=ppt/slides/slide6.xml><?xml version="1.0" encoding="utf-8"?>
-<p:sld xmlns:a="http://schemas.openxmlformats.org/drawingml/2006/main" xmlns:p="http://schemas.openxmlformats.org/presentationml/2006/main" xmlns:r="http://schemas.openxmlformats.org/officeDocument/2006/relationships">
+<p:sld xmlns:a="http://schemas.openxmlformats.org/drawingml/2006/main" xmlns:r="http://schemas.openxmlformats.org/officeDocument/2006/relationships" xmlns:p="http://schemas.openxmlformats.org/presentationml/2006/main">
   <p:cSld>
     <p:bg>
       <p:bgPr>
@@ -6548,7 +6600,14 @@
         <p:cNvGrpSpPr/>
         <p:nvPr/>
       </p:nvGrpSpPr>
-      <p:grpSpPr/>
+      <p:grpSpPr>
+        <a:xfrm>
+          <a:off x="0" y="0"/>
+          <a:ext cx="0" cy="0"/>
+          <a:chOff x="0" y="0"/>
+          <a:chExt cx="0" cy="0"/>
+        </a:xfrm>
+      </p:grpSpPr>
       <p:sp>
         <p:nvSpPr>
           <p:cNvPr id="2" name="TextBox 1"/>
@@ -6626,6 +6685,7 @@
           <a:lstStyle/>
           <a:p>
             <a:pPr algn="ctr"/>
+            <a:endParaRPr/>
           </a:p>
         </p:txBody>
       </p:sp>
@@ -6671,6 +6731,7 @@
           <a:lstStyle/>
           <a:p>
             <a:pPr algn="ctr"/>
+            <a:endParaRPr/>
           </a:p>
         </p:txBody>
       </p:sp>
@@ -6697,15 +6758,7 @@
           <a:lstStyle/>
           <a:p>
             <a:pPr algn="ctr"/>
-            <a:r>
-              <a:rPr sz="1300" b="1" i="0">
-                <a:solidFill>
-                  <a:srgbClr val="0A0408"/>
-                </a:solidFill>
-                <a:latin typeface="Calibri"/>
-              </a:rPr>
-              <a:t/>
-            </a:r>
+            <a:endParaRPr/>
           </a:p>
         </p:txBody>
       </p:sp>
@@ -6751,6 +6804,7 @@
           <a:lstStyle/>
           <a:p>
             <a:pPr algn="ctr"/>
+            <a:endParaRPr/>
           </a:p>
         </p:txBody>
       </p:sp>
@@ -6831,6 +6885,7 @@
           <a:lstStyle/>
           <a:p>
             <a:pPr algn="ctr"/>
+            <a:endParaRPr/>
           </a:p>
         </p:txBody>
       </p:sp>
@@ -6911,6 +6966,7 @@
           <a:lstStyle/>
           <a:p>
             <a:pPr algn="ctr"/>
+            <a:endParaRPr/>
           </a:p>
         </p:txBody>
       </p:sp>
@@ -6991,6 +7047,7 @@
           <a:lstStyle/>
           <a:p>
             <a:pPr algn="ctr"/>
+            <a:endParaRPr/>
           </a:p>
         </p:txBody>
       </p:sp>
@@ -7071,6 +7128,7 @@
           <a:lstStyle/>
           <a:p>
             <a:pPr algn="ctr"/>
+            <a:endParaRPr/>
           </a:p>
         </p:txBody>
       </p:sp>
@@ -7151,6 +7209,7 @@
           <a:lstStyle/>
           <a:p>
             <a:pPr algn="ctr"/>
+            <a:endParaRPr/>
           </a:p>
         </p:txBody>
       </p:sp>
@@ -7231,6 +7290,7 @@
           <a:lstStyle/>
           <a:p>
             <a:pPr algn="ctr"/>
+            <a:endParaRPr/>
           </a:p>
         </p:txBody>
       </p:sp>
@@ -7311,6 +7371,7 @@
           <a:lstStyle/>
           <a:p>
             <a:pPr algn="ctr"/>
+            <a:endParaRPr/>
           </a:p>
         </p:txBody>
       </p:sp>
@@ -7391,6 +7452,7 @@
           <a:lstStyle/>
           <a:p>
             <a:pPr algn="ctr"/>
+            <a:endParaRPr/>
           </a:p>
         </p:txBody>
       </p:sp>
@@ -7471,6 +7533,7 @@
           <a:lstStyle/>
           <a:p>
             <a:pPr algn="ctr"/>
+            <a:endParaRPr/>
           </a:p>
         </p:txBody>
       </p:sp>
@@ -7551,6 +7614,7 @@
           <a:lstStyle/>
           <a:p>
             <a:pPr algn="ctr"/>
+            <a:endParaRPr/>
           </a:p>
         </p:txBody>
       </p:sp>
@@ -7631,6 +7695,7 @@
           <a:lstStyle/>
           <a:p>
             <a:pPr algn="ctr"/>
+            <a:endParaRPr/>
           </a:p>
         </p:txBody>
       </p:sp>
@@ -7711,6 +7776,7 @@
           <a:lstStyle/>
           <a:p>
             <a:pPr algn="ctr"/>
+            <a:endParaRPr/>
           </a:p>
         </p:txBody>
       </p:sp>
@@ -7791,6 +7857,7 @@
           <a:lstStyle/>
           <a:p>
             <a:pPr algn="ctr"/>
+            <a:endParaRPr/>
           </a:p>
         </p:txBody>
       </p:sp>
@@ -7871,6 +7938,7 @@
           <a:lstStyle/>
           <a:p>
             <a:pPr algn="ctr"/>
+            <a:endParaRPr/>
           </a:p>
         </p:txBody>
       </p:sp>
@@ -7951,6 +8019,7 @@
           <a:lstStyle/>
           <a:p>
             <a:pPr algn="ctr"/>
+            <a:endParaRPr/>
           </a:p>
         </p:txBody>
       </p:sp>
@@ -8031,6 +8100,7 @@
           <a:lstStyle/>
           <a:p>
             <a:pPr algn="ctr"/>
+            <a:endParaRPr/>
           </a:p>
         </p:txBody>
       </p:sp>
@@ -8111,6 +8181,7 @@
           <a:lstStyle/>
           <a:p>
             <a:pPr algn="ctr"/>
+            <a:endParaRPr/>
           </a:p>
         </p:txBody>
       </p:sp>
@@ -8191,6 +8262,7 @@
           <a:lstStyle/>
           <a:p>
             <a:pPr algn="ctr"/>
+            <a:endParaRPr/>
           </a:p>
         </p:txBody>
       </p:sp>
@@ -8271,6 +8343,7 @@
           <a:lstStyle/>
           <a:p>
             <a:pPr algn="ctr"/>
+            <a:endParaRPr/>
           </a:p>
         </p:txBody>
       </p:sp>
@@ -8351,6 +8424,7 @@
           <a:lstStyle/>
           <a:p>
             <a:pPr algn="ctr"/>
+            <a:endParaRPr/>
           </a:p>
         </p:txBody>
       </p:sp>
@@ -8431,6 +8505,7 @@
           <a:lstStyle/>
           <a:p>
             <a:pPr algn="ctr"/>
+            <a:endParaRPr/>
           </a:p>
         </p:txBody>
       </p:sp>
@@ -8511,6 +8586,7 @@
           <a:lstStyle/>
           <a:p>
             <a:pPr algn="ctr"/>
+            <a:endParaRPr/>
           </a:p>
         </p:txBody>
       </p:sp>
@@ -8593,7 +8669,7 @@
 </file>
 
 <file path=ppt/slides/slide7.xml><?xml version="1.0" encoding="utf-8"?>
-<p:sld xmlns:a="http://schemas.openxmlformats.org/drawingml/2006/main" xmlns:p="http://schemas.openxmlformats.org/presentationml/2006/main" xmlns:r="http://schemas.openxmlformats.org/officeDocument/2006/relationships">
+<p:sld xmlns:a="http://schemas.openxmlformats.org/drawingml/2006/main" xmlns:r="http://schemas.openxmlformats.org/officeDocument/2006/relationships" xmlns:p="http://schemas.openxmlformats.org/presentationml/2006/main">
   <p:cSld>
     <p:bg>
       <p:bgPr>
@@ -8609,7 +8685,14 @@
         <p:cNvGrpSpPr/>
         <p:nvPr/>
       </p:nvGrpSpPr>
-      <p:grpSpPr/>
+      <p:grpSpPr>
+        <a:xfrm>
+          <a:off x="0" y="0"/>
+          <a:ext cx="0" cy="0"/>
+          <a:chOff x="0" y="0"/>
+          <a:chExt cx="0" cy="0"/>
+        </a:xfrm>
+      </p:grpSpPr>
       <p:sp>
         <p:nvSpPr>
           <p:cNvPr id="2" name="TextBox 1"/>
@@ -8687,6 +8770,7 @@
           <a:lstStyle/>
           <a:p>
             <a:pPr algn="ctr"/>
+            <a:endParaRPr/>
           </a:p>
         </p:txBody>
       </p:sp>
@@ -8767,6 +8851,7 @@
           <a:lstStyle/>
           <a:p>
             <a:pPr algn="ctr"/>
+            <a:endParaRPr/>
           </a:p>
         </p:txBody>
       </p:sp>
@@ -8812,6 +8897,7 @@
           <a:lstStyle/>
           <a:p>
             <a:pPr algn="ctr"/>
+            <a:endParaRPr/>
           </a:p>
         </p:txBody>
       </p:sp>
@@ -8999,6 +9085,7 @@
           <a:lstStyle/>
           <a:p>
             <a:pPr algn="ctr"/>
+            <a:endParaRPr/>
           </a:p>
         </p:txBody>
       </p:sp>
@@ -9187,6 +9274,7 @@
           <a:lstStyle/>
           <a:p>
             <a:pPr algn="ctr"/>
+            <a:endParaRPr/>
           </a:p>
         </p:txBody>
       </p:sp>
@@ -9377,7 +9465,7 @@
 </file>
 
 <file path=ppt/slides/slide8.xml><?xml version="1.0" encoding="utf-8"?>
-<p:sld xmlns:a="http://schemas.openxmlformats.org/drawingml/2006/main" xmlns:p="http://schemas.openxmlformats.org/presentationml/2006/main" xmlns:r="http://schemas.openxmlformats.org/officeDocument/2006/relationships">
+<p:sld xmlns:a="http://schemas.openxmlformats.org/drawingml/2006/main" xmlns:r="http://schemas.openxmlformats.org/officeDocument/2006/relationships" xmlns:p="http://schemas.openxmlformats.org/presentationml/2006/main">
   <p:cSld>
     <p:bg>
       <p:bgPr>
@@ -9393,7 +9481,14 @@
         <p:cNvGrpSpPr/>
         <p:nvPr/>
       </p:nvGrpSpPr>
-      <p:grpSpPr/>
+      <p:grpSpPr>
+        <a:xfrm>
+          <a:off x="0" y="0"/>
+          <a:ext cx="0" cy="0"/>
+          <a:chOff x="0" y="0"/>
+          <a:chExt cx="0" cy="0"/>
+        </a:xfrm>
+      </p:grpSpPr>
       <p:sp>
         <p:nvSpPr>
           <p:cNvPr id="2" name="TextBox 1"/>
@@ -9471,6 +9566,7 @@
           <a:lstStyle/>
           <a:p>
             <a:pPr algn="ctr"/>
+            <a:endParaRPr/>
           </a:p>
         </p:txBody>
       </p:sp>
@@ -9761,6 +9857,7 @@
           <a:lstStyle/>
           <a:p>
             <a:pPr algn="ctr"/>
+            <a:endParaRPr/>
           </a:p>
         </p:txBody>
       </p:sp>
@@ -10158,7 +10255,7 @@
 </file>
 
 <file path=ppt/slides/slide9.xml><?xml version="1.0" encoding="utf-8"?>
-<p:sld xmlns:a="http://schemas.openxmlformats.org/drawingml/2006/main" xmlns:p="http://schemas.openxmlformats.org/presentationml/2006/main" xmlns:r="http://schemas.openxmlformats.org/officeDocument/2006/relationships">
+<p:sld xmlns:a="http://schemas.openxmlformats.org/drawingml/2006/main" xmlns:r="http://schemas.openxmlformats.org/officeDocument/2006/relationships" xmlns:p="http://schemas.openxmlformats.org/presentationml/2006/main">
   <p:cSld>
     <p:bg>
       <p:bgPr>
@@ -10174,7 +10271,14 @@
         <p:cNvGrpSpPr/>
         <p:nvPr/>
       </p:nvGrpSpPr>
-      <p:grpSpPr/>
+      <p:grpSpPr>
+        <a:xfrm>
+          <a:off x="0" y="0"/>
+          <a:ext cx="0" cy="0"/>
+          <a:chOff x="0" y="0"/>
+          <a:chExt cx="0" cy="0"/>
+        </a:xfrm>
+      </p:grpSpPr>
       <p:sp>
         <p:nvSpPr>
           <p:cNvPr id="2" name="TextBox 1"/>
@@ -10252,41 +10356,7 @@
           <a:lstStyle/>
           <a:p>
             <a:pPr algn="ctr"/>
-          </a:p>
-        </p:txBody>
-      </p:sp>
-      <p:sp>
-        <p:nvSpPr>
-          <p:cNvPr id="4" name="TextBox 3"/>
-          <p:cNvSpPr txBox="1"/>
-          <p:nvPr/>
-        </p:nvSpPr>
-        <p:spPr>
-          <a:xfrm>
-            <a:off x="640080" y="1600200"/>
-            <a:ext cx="10881360" cy="548640"/>
-          </a:xfrm>
-          <a:prstGeom prst="rect">
-            <a:avLst/>
-          </a:prstGeom>
-          <a:noFill/>
-        </p:spPr>
-        <p:txBody>
-          <a:bodyPr wrap="square">
-            <a:spAutoFit/>
-          </a:bodyPr>
-          <a:lstStyle/>
-          <a:p>
-            <a:pPr algn="l"/>
-            <a:r>
-              <a:rPr sz="1600" b="0" i="1">
-                <a:solidFill>
-                  <a:srgbClr val="6B5E5A"/>
-                </a:solidFill>
-                <a:latin typeface="Calibri"/>
-              </a:rPr>
-              <a:t>Add your team members here — names, roles, and one-line backgrounds.</a:t>
-            </a:r>
+            <a:endParaRPr/>
           </a:p>
         </p:txBody>
       </p:sp>
@@ -10298,8 +10368,8 @@
         </p:nvSpPr>
         <p:spPr>
           <a:xfrm>
-            <a:off x="640080" y="2377440"/>
-            <a:ext cx="3383280" cy="3200400"/>
+            <a:off x="640080" y="1979871"/>
+            <a:ext cx="3383280" cy="3672177"/>
           </a:xfrm>
           <a:prstGeom prst="rect">
             <a:avLst/>
@@ -10332,6 +10402,7 @@
           <a:lstStyle/>
           <a:p>
             <a:pPr algn="ctr"/>
+            <a:endParaRPr/>
           </a:p>
         </p:txBody>
       </p:sp>
@@ -10343,7 +10414,7 @@
         </p:nvSpPr>
         <p:spPr>
           <a:xfrm>
-            <a:off x="1920240" y="2606040"/>
+            <a:off x="1920240" y="2208472"/>
             <a:ext cx="822960" cy="822960"/>
           </a:xfrm>
           <a:prstGeom prst="ellipse">
@@ -10390,8 +10461,8 @@
         </p:nvSpPr>
         <p:spPr>
           <a:xfrm>
-            <a:off x="777240" y="3611880"/>
-            <a:ext cx="3108960" cy="457200"/>
+            <a:off x="777240" y="3214312"/>
+            <a:ext cx="3108960" cy="338554"/>
           </a:xfrm>
           <a:prstGeom prst="rect">
             <a:avLst/>
@@ -10406,14 +10477,20 @@
           <a:p>
             <a:pPr algn="ctr"/>
             <a:r>
-              <a:rPr sz="1600" b="1" i="0">
+              <a:rPr lang="en-CA" sz="1600" b="1" i="0" dirty="0">
                 <a:solidFill>
                   <a:srgbClr val="0A0408"/>
                 </a:solidFill>
                 <a:latin typeface="Calibri"/>
               </a:rPr>
-              <a:t>Name Here</a:t>
-            </a:r>
+              <a:t>Maggie Yang</a:t>
+            </a:r>
+            <a:endParaRPr sz="1600" b="1" i="0" dirty="0">
+              <a:solidFill>
+                <a:srgbClr val="0A0408"/>
+              </a:solidFill>
+              <a:latin typeface="Calibri"/>
+            </a:endParaRPr>
           </a:p>
         </p:txBody>
       </p:sp>
@@ -10425,8 +10502,8 @@
         </p:nvSpPr>
         <p:spPr>
           <a:xfrm>
-            <a:off x="777240" y="4069080"/>
-            <a:ext cx="3108960" cy="365760"/>
+            <a:off x="777240" y="3671512"/>
+            <a:ext cx="3108960" cy="292388"/>
           </a:xfrm>
           <a:prstGeom prst="rect">
             <a:avLst/>
@@ -10441,14 +10518,20 @@
           <a:p>
             <a:pPr algn="ctr"/>
             <a:r>
-              <a:rPr sz="1300" b="0" i="0">
+              <a:rPr lang="en-CA" sz="1300" b="0" i="0" dirty="0">
                 <a:solidFill>
                   <a:srgbClr val="C9A49A"/>
                 </a:solidFill>
                 <a:latin typeface="Calibri"/>
               </a:rPr>
-              <a:t>Role / Background</a:t>
-            </a:r>
+              <a:t>CEO &amp; Product</a:t>
+            </a:r>
+            <a:endParaRPr sz="1300" b="0" i="0" dirty="0">
+              <a:solidFill>
+                <a:srgbClr val="C9A49A"/>
+              </a:solidFill>
+              <a:latin typeface="Calibri"/>
+            </a:endParaRPr>
           </a:p>
         </p:txBody>
       </p:sp>
@@ -10460,8 +10543,8 @@
         </p:nvSpPr>
         <p:spPr>
           <a:xfrm>
-            <a:off x="777240" y="4526280"/>
-            <a:ext cx="3108960" cy="640080"/>
+            <a:off x="777240" y="4128712"/>
+            <a:ext cx="3108960" cy="1384995"/>
           </a:xfrm>
           <a:prstGeom prst="rect">
             <a:avLst/>
@@ -10476,14 +10559,20 @@
           <a:p>
             <a:pPr algn="ctr"/>
             <a:r>
-              <a:rPr sz="1200" b="0" i="0">
+              <a:rPr lang="en-CA" sz="1200" b="0" i="0" dirty="0">
                 <a:solidFill>
                   <a:srgbClr val="6B5E5A"/>
                 </a:solidFill>
                 <a:latin typeface="Calibri"/>
               </a:rPr>
-              <a:t>One line about this person's relevant experience.</a:t>
-            </a:r>
+              <a:t>Former AI Product Manager at Huawei, where she owned search and analytics platforms across international markets — driving +47% DAU and +107% CTR. MBA from UBC Sauder and Master's from Columbia. Recently planned two 150-guest weddings and lived every pain point this product solves.</a:t>
+            </a:r>
+            <a:endParaRPr sz="1200" b="0" i="0" dirty="0">
+              <a:solidFill>
+                <a:srgbClr val="6B5E5A"/>
+              </a:solidFill>
+              <a:latin typeface="Calibri"/>
+            </a:endParaRPr>
           </a:p>
         </p:txBody>
       </p:sp>
@@ -10495,8 +10584,8 @@
         </p:nvSpPr>
         <p:spPr>
           <a:xfrm>
-            <a:off x="4389119" y="2377440"/>
-            <a:ext cx="3383280" cy="3200400"/>
+            <a:off x="4389119" y="1979872"/>
+            <a:ext cx="3383280" cy="3672176"/>
           </a:xfrm>
           <a:prstGeom prst="rect">
             <a:avLst/>
@@ -10529,6 +10618,7 @@
           <a:lstStyle/>
           <a:p>
             <a:pPr algn="ctr"/>
+            <a:endParaRPr/>
           </a:p>
         </p:txBody>
       </p:sp>
@@ -10540,7 +10630,7 @@
         </p:nvSpPr>
         <p:spPr>
           <a:xfrm>
-            <a:off x="5669279" y="2606040"/>
+            <a:off x="5669279" y="2208472"/>
             <a:ext cx="822960" cy="822960"/>
           </a:xfrm>
           <a:prstGeom prst="ellipse">
@@ -10587,8 +10677,8 @@
         </p:nvSpPr>
         <p:spPr>
           <a:xfrm>
-            <a:off x="4526279" y="3611880"/>
-            <a:ext cx="3108960" cy="457200"/>
+            <a:off x="4526279" y="3214312"/>
+            <a:ext cx="3108960" cy="338554"/>
           </a:xfrm>
           <a:prstGeom prst="rect">
             <a:avLst/>
@@ -10603,14 +10693,20 @@
           <a:p>
             <a:pPr algn="ctr"/>
             <a:r>
-              <a:rPr sz="1600" b="1" i="0">
+              <a:rPr lang="en-CA" sz="1600" b="1" i="0" dirty="0">
                 <a:solidFill>
                   <a:srgbClr val="0A0408"/>
                 </a:solidFill>
                 <a:latin typeface="Calibri"/>
               </a:rPr>
-              <a:t>Name Here</a:t>
-            </a:r>
+              <a:t>Yelin Fan</a:t>
+            </a:r>
+            <a:endParaRPr sz="1600" b="1" i="0" dirty="0">
+              <a:solidFill>
+                <a:srgbClr val="0A0408"/>
+              </a:solidFill>
+              <a:latin typeface="Calibri"/>
+            </a:endParaRPr>
           </a:p>
         </p:txBody>
       </p:sp>
@@ -10622,8 +10718,8 @@
         </p:nvSpPr>
         <p:spPr>
           <a:xfrm>
-            <a:off x="4526279" y="4069080"/>
-            <a:ext cx="3108960" cy="365760"/>
+            <a:off x="4526279" y="3671512"/>
+            <a:ext cx="3108960" cy="292388"/>
           </a:xfrm>
           <a:prstGeom prst="rect">
             <a:avLst/>
@@ -10638,14 +10734,20 @@
           <a:p>
             <a:pPr algn="ctr"/>
             <a:r>
-              <a:rPr sz="1300" b="0" i="0">
+              <a:rPr lang="en-CA" sz="1300" b="0" i="0" dirty="0">
                 <a:solidFill>
                   <a:srgbClr val="C9A49A"/>
                 </a:solidFill>
                 <a:latin typeface="Calibri"/>
               </a:rPr>
-              <a:t>Role / Background</a:t>
-            </a:r>
+              <a:t>Developer</a:t>
+            </a:r>
+            <a:endParaRPr sz="1300" b="0" i="0" dirty="0">
+              <a:solidFill>
+                <a:srgbClr val="C9A49A"/>
+              </a:solidFill>
+              <a:latin typeface="Calibri"/>
+            </a:endParaRPr>
           </a:p>
         </p:txBody>
       </p:sp>
@@ -10657,8 +10759,8 @@
         </p:nvSpPr>
         <p:spPr>
           <a:xfrm>
-            <a:off x="4526279" y="4526280"/>
-            <a:ext cx="3108960" cy="640080"/>
+            <a:off x="4526279" y="4128712"/>
+            <a:ext cx="3108960" cy="1384995"/>
           </a:xfrm>
           <a:prstGeom prst="rect">
             <a:avLst/>
@@ -10673,14 +10775,20 @@
           <a:p>
             <a:pPr algn="ctr"/>
             <a:r>
-              <a:rPr sz="1200" b="0" i="0">
+              <a:rPr lang="en-CA" sz="1200" b="0" i="0" dirty="0">
                 <a:solidFill>
                   <a:srgbClr val="6B5E5A"/>
                 </a:solidFill>
                 <a:latin typeface="Calibri"/>
               </a:rPr>
-              <a:t>One line about this person's relevant experience.</a:t>
-            </a:r>
+              <a:t>Data scientist and engineer with expertise in machine learning, analytics, and full-stack development. Master of Business Analytics from UBC Sauder, B.Sc. from McGill. 4+ years as Senior Analyst at PHSA and former Senior Business Analyst at TELUS Health, building data-driven systems at scale.</a:t>
+            </a:r>
+            <a:endParaRPr sz="1200" b="0" i="0" dirty="0">
+              <a:solidFill>
+                <a:srgbClr val="6B5E5A"/>
+              </a:solidFill>
+              <a:latin typeface="Calibri"/>
+            </a:endParaRPr>
           </a:p>
         </p:txBody>
       </p:sp>
@@ -10692,8 +10800,8 @@
         </p:nvSpPr>
         <p:spPr>
           <a:xfrm>
-            <a:off x="8138158" y="2377440"/>
-            <a:ext cx="3383280" cy="3200400"/>
+            <a:off x="8138158" y="1979872"/>
+            <a:ext cx="3383280" cy="3672176"/>
           </a:xfrm>
           <a:prstGeom prst="rect">
             <a:avLst/>
@@ -10726,6 +10834,7 @@
           <a:lstStyle/>
           <a:p>
             <a:pPr algn="ctr"/>
+            <a:endParaRPr/>
           </a:p>
         </p:txBody>
       </p:sp>
@@ -10737,7 +10846,7 @@
         </p:nvSpPr>
         <p:spPr>
           <a:xfrm>
-            <a:off x="9418318" y="2606040"/>
+            <a:off x="9418318" y="2208472"/>
             <a:ext cx="822960" cy="822960"/>
           </a:xfrm>
           <a:prstGeom prst="ellipse">
@@ -10769,10 +10878,7 @@
           <a:lstStyle/>
           <a:p>
             <a:pPr algn="ctr"/>
-            <a:r>
-              <a:rPr sz="2400"/>
-              <a:t>👤</a:t>
-            </a:r>
+            <a:endParaRPr sz="2400" dirty="0"/>
           </a:p>
         </p:txBody>
       </p:sp>
@@ -10784,8 +10890,8 @@
         </p:nvSpPr>
         <p:spPr>
           <a:xfrm>
-            <a:off x="8275318" y="3611880"/>
-            <a:ext cx="3108960" cy="457200"/>
+            <a:off x="8275318" y="3214312"/>
+            <a:ext cx="3108960" cy="338554"/>
           </a:xfrm>
           <a:prstGeom prst="rect">
             <a:avLst/>
@@ -10800,14 +10906,20 @@
           <a:p>
             <a:pPr algn="ctr"/>
             <a:r>
-              <a:rPr sz="1600" b="1" i="0">
+              <a:rPr lang="en-CA" sz="1600" b="1" i="0" dirty="0">
                 <a:solidFill>
                   <a:srgbClr val="0A0408"/>
                 </a:solidFill>
                 <a:latin typeface="Calibri"/>
               </a:rPr>
-              <a:t>Name Here</a:t>
-            </a:r>
+              <a:t>Kai Li</a:t>
+            </a:r>
+            <a:endParaRPr sz="1600" b="1" i="0" dirty="0">
+              <a:solidFill>
+                <a:srgbClr val="0A0408"/>
+              </a:solidFill>
+              <a:latin typeface="Calibri"/>
+            </a:endParaRPr>
           </a:p>
         </p:txBody>
       </p:sp>
@@ -10819,8 +10931,8 @@
         </p:nvSpPr>
         <p:spPr>
           <a:xfrm>
-            <a:off x="8275318" y="4069080"/>
-            <a:ext cx="3108960" cy="365760"/>
+            <a:off x="8275318" y="3671512"/>
+            <a:ext cx="3108960" cy="292388"/>
           </a:xfrm>
           <a:prstGeom prst="rect">
             <a:avLst/>
@@ -10835,14 +10947,20 @@
           <a:p>
             <a:pPr algn="ctr"/>
             <a:r>
-              <a:rPr sz="1300" b="0" i="0">
+              <a:rPr lang="en-CA" sz="1300" dirty="0">
                 <a:solidFill>
                   <a:srgbClr val="C9A49A"/>
                 </a:solidFill>
                 <a:latin typeface="Calibri"/>
               </a:rPr>
-              <a:t>Role / Background</a:t>
-            </a:r>
+              <a:t>Developer &amp; Business Development</a:t>
+            </a:r>
+            <a:endParaRPr sz="1300" b="0" i="0" dirty="0">
+              <a:solidFill>
+                <a:srgbClr val="C9A49A"/>
+              </a:solidFill>
+              <a:latin typeface="Calibri"/>
+            </a:endParaRPr>
           </a:p>
         </p:txBody>
       </p:sp>
@@ -10854,8 +10972,8 @@
         </p:nvSpPr>
         <p:spPr>
           <a:xfrm>
-            <a:off x="8275318" y="4526280"/>
-            <a:ext cx="3108960" cy="640080"/>
+            <a:off x="8275318" y="4128712"/>
+            <a:ext cx="3108960" cy="1384995"/>
           </a:xfrm>
           <a:prstGeom prst="rect">
             <a:avLst/>
@@ -10870,17 +10988,148 @@
           <a:p>
             <a:pPr algn="ctr"/>
             <a:r>
-              <a:rPr sz="1200" b="0" i="0">
+              <a:rPr lang="en-CA" sz="1200" b="0" i="0" dirty="0">
                 <a:solidFill>
                   <a:srgbClr val="6B5E5A"/>
                 </a:solidFill>
                 <a:latin typeface="Calibri"/>
               </a:rPr>
-              <a:t>One line about this person's relevant experience.</a:t>
-            </a:r>
-          </a:p>
-        </p:txBody>
-      </p:sp>
+              <a:t>Business analyst with a background in event management and large-scale event operations. Master of Business Analytics from UBC Sauder and Master's from Columbia. Strong in Python, BI, and rapid prototyping. Co-planned two 150-guest weddings — and decided no couple should have to do it without better tools.</a:t>
+            </a:r>
+            <a:endParaRPr sz="1200" b="0" i="0" dirty="0">
+              <a:solidFill>
+                <a:srgbClr val="6B5E5A"/>
+              </a:solidFill>
+              <a:latin typeface="Calibri"/>
+            </a:endParaRPr>
+          </a:p>
+        </p:txBody>
+      </p:sp>
+      <p:pic>
+        <p:nvPicPr>
+          <p:cNvPr id="21" name="图片 20">
+            <a:extLst>
+              <a:ext uri="{FF2B5EF4-FFF2-40B4-BE49-F238E27FC236}">
+                <a16:creationId xmlns:a16="http://schemas.microsoft.com/office/drawing/2014/main" id="{E41CEF82-FEA5-1A92-FE7A-714DBD8BBE66}"/>
+              </a:ext>
+            </a:extLst>
+          </p:cNvPr>
+          <p:cNvPicPr>
+            <a:picLocks noChangeAspect="1"/>
+          </p:cNvPicPr>
+          <p:nvPr/>
+        </p:nvPicPr>
+        <p:blipFill rotWithShape="1">
+          <a:blip r:embed="rId2"/>
+          <a:srcRect t="7400" b="26066"/>
+          <a:stretch>
+            <a:fillRect/>
+          </a:stretch>
+        </p:blipFill>
+        <p:spPr>
+          <a:xfrm>
+            <a:off x="9418319" y="2208473"/>
+            <a:ext cx="822960" cy="822960"/>
+          </a:xfrm>
+          <a:prstGeom prst="ellipse">
+            <a:avLst/>
+          </a:prstGeom>
+        </p:spPr>
+      </p:pic>
+      <p:pic>
+        <p:nvPicPr>
+          <p:cNvPr id="1026" name="Picture 2" descr="Profile image">
+            <a:extLst>
+              <a:ext uri="{FF2B5EF4-FFF2-40B4-BE49-F238E27FC236}">
+                <a16:creationId xmlns:a16="http://schemas.microsoft.com/office/drawing/2014/main" id="{4AA8AAA7-B0FD-87AE-F775-A6E9C5B5E73C}"/>
+              </a:ext>
+            </a:extLst>
+          </p:cNvPr>
+          <p:cNvPicPr>
+            <a:picLocks noChangeAspect="1" noChangeArrowheads="1"/>
+          </p:cNvPicPr>
+          <p:nvPr/>
+        </p:nvPicPr>
+        <p:blipFill rotWithShape="1">
+          <a:blip r:embed="rId3">
+            <a:extLst>
+              <a:ext uri="{28A0092B-C50C-407E-A947-70E740481C1C}">
+                <a14:useLocalDpi xmlns:a14="http://schemas.microsoft.com/office/drawing/2010/main" val="0"/>
+              </a:ext>
+            </a:extLst>
+          </a:blip>
+          <a:srcRect/>
+          <a:stretch>
+            <a:fillRect/>
+          </a:stretch>
+        </p:blipFill>
+        <p:spPr bwMode="auto">
+          <a:xfrm>
+            <a:off x="5669280" y="2208474"/>
+            <a:ext cx="822959" cy="822959"/>
+          </a:xfrm>
+          <a:prstGeom prst="ellipse">
+            <a:avLst/>
+          </a:prstGeom>
+          <a:noFill/>
+          <a:extLst>
+            <a:ext uri="{909E8E84-426E-40DD-AFC4-6F175D3DCCD1}">
+              <a14:hiddenFill xmlns:a14="http://schemas.microsoft.com/office/drawing/2010/main">
+                <a:solidFill>
+                  <a:srgbClr val="FFFFFF"/>
+                </a:solidFill>
+              </a14:hiddenFill>
+            </a:ext>
+          </a:extLst>
+        </p:spPr>
+      </p:pic>
+      <p:pic>
+        <p:nvPicPr>
+          <p:cNvPr id="1028" name="Picture 4" descr="Profile image">
+            <a:extLst>
+              <a:ext uri="{FF2B5EF4-FFF2-40B4-BE49-F238E27FC236}">
+                <a16:creationId xmlns:a16="http://schemas.microsoft.com/office/drawing/2014/main" id="{E5C32B1E-6062-03D4-EF11-8D5A2D2184F3}"/>
+              </a:ext>
+            </a:extLst>
+          </p:cNvPr>
+          <p:cNvPicPr>
+            <a:picLocks noChangeAspect="1" noChangeArrowheads="1"/>
+          </p:cNvPicPr>
+          <p:nvPr/>
+        </p:nvPicPr>
+        <p:blipFill rotWithShape="1">
+          <a:blip r:embed="rId4">
+            <a:extLst>
+              <a:ext uri="{28A0092B-C50C-407E-A947-70E740481C1C}">
+                <a14:useLocalDpi xmlns:a14="http://schemas.microsoft.com/office/drawing/2010/main" val="0"/>
+              </a:ext>
+            </a:extLst>
+          </a:blip>
+          <a:srcRect/>
+          <a:stretch>
+            <a:fillRect/>
+          </a:stretch>
+        </p:blipFill>
+        <p:spPr bwMode="auto">
+          <a:xfrm>
+            <a:off x="1920239" y="2208474"/>
+            <a:ext cx="822960" cy="822960"/>
+          </a:xfrm>
+          <a:prstGeom prst="ellipse">
+            <a:avLst/>
+          </a:prstGeom>
+          <a:noFill/>
+          <a:extLst>
+            <a:ext uri="{909E8E84-426E-40DD-AFC4-6F175D3DCCD1}">
+              <a14:hiddenFill xmlns:a14="http://schemas.microsoft.com/office/drawing/2010/main">
+                <a:solidFill>
+                  <a:srgbClr val="FFFFFF"/>
+                </a:solidFill>
+              </a14:hiddenFill>
+            </a:ext>
+          </a:extLst>
+        </p:spPr>
+      </p:pic>
     </p:spTree>
   </p:cSld>
   <p:clrMapOvr>

</xml_diff>